<commit_message>
corrected typo in the table 31r2 to 41r2
</commit_message>
<xml_diff>
--- a/chapter_04/tables/forecasts_types.pptx
+++ b/chapter_04/tables/forecasts_types.pptx
@@ -115,178 +115,26 @@
 <file path=ppt/changesInfos/changesInfo1.xml><?xml version="1.0" encoding="utf-8"?>
 <pc:chgInfo xmlns:a="http://schemas.openxmlformats.org/drawingml/2006/main" xmlns:r="http://schemas.openxmlformats.org/officeDocument/2006/relationships" xmlns:ac="http://schemas.microsoft.com/office/drawing/2013/main/command" xmlns:pc="http://schemas.microsoft.com/office/powerpoint/2013/main/command">
   <pc:docChgLst>
-    <pc:chgData name="Fatima Pillosu" userId="a6295d4dc9e22643" providerId="LiveId" clId="{DC7F69EF-7870-46FC-A397-B1029EF7C406}"/>
-    <pc:docChg chg="custSel modSld">
-      <pc:chgData name="Fatima Pillosu" userId="a6295d4dc9e22643" providerId="LiveId" clId="{DC7F69EF-7870-46FC-A397-B1029EF7C406}" dt="2025-05-13T11:05:49.388" v="3"/>
+    <pc:chgData name="Fatima Pillosu" userId="a6295d4dc9e22643" providerId="LiveId" clId="{87453732-75AC-4426-B5D3-B7C69C2D4F54}"/>
+    <pc:docChg chg="modSld">
+      <pc:chgData name="Fatima Pillosu" userId="a6295d4dc9e22643" providerId="LiveId" clId="{87453732-75AC-4426-B5D3-B7C69C2D4F54}" dt="2026-01-15T10:11:32.398" v="1" actId="20577"/>
       <pc:docMkLst>
         <pc:docMk/>
       </pc:docMkLst>
-      <pc:sldChg chg="addSp delSp modSp mod">
-        <pc:chgData name="Fatima Pillosu" userId="a6295d4dc9e22643" providerId="LiveId" clId="{DC7F69EF-7870-46FC-A397-B1029EF7C406}" dt="2025-05-13T11:05:49.388" v="3"/>
+      <pc:sldChg chg="modSp mod">
+        <pc:chgData name="Fatima Pillosu" userId="a6295d4dc9e22643" providerId="LiveId" clId="{87453732-75AC-4426-B5D3-B7C69C2D4F54}" dt="2026-01-15T10:11:32.398" v="1" actId="20577"/>
         <pc:sldMkLst>
           <pc:docMk/>
           <pc:sldMk cId="3020345181" sldId="257"/>
         </pc:sldMkLst>
-        <pc:spChg chg="add del">
-          <ac:chgData name="Fatima Pillosu" userId="a6295d4dc9e22643" providerId="LiveId" clId="{DC7F69EF-7870-46FC-A397-B1029EF7C406}" dt="2025-05-13T11:05:35.401" v="1" actId="478"/>
-          <ac:spMkLst>
-            <pc:docMk/>
-            <pc:sldMk cId="3020345181" sldId="257"/>
-            <ac:spMk id="5" creationId="{A7EB56B3-F12C-8E69-1F3B-9155CE8BF3C4}"/>
-          </ac:spMkLst>
-        </pc:spChg>
-        <pc:graphicFrameChg chg="del">
-          <ac:chgData name="Fatima Pillosu" userId="a6295d4dc9e22643" providerId="LiveId" clId="{DC7F69EF-7870-46FC-A397-B1029EF7C406}" dt="2025-05-13T11:05:36.709" v="2" actId="21"/>
-          <ac:graphicFrameMkLst>
-            <pc:docMk/>
-            <pc:sldMk cId="3020345181" sldId="257"/>
-            <ac:graphicFrameMk id="4" creationId="{15623DAB-A4E1-DF1C-9B96-E2C1CE9DE49A}"/>
-          </ac:graphicFrameMkLst>
-        </pc:graphicFrameChg>
-        <pc:graphicFrameChg chg="add mod">
-          <ac:chgData name="Fatima Pillosu" userId="a6295d4dc9e22643" providerId="LiveId" clId="{DC7F69EF-7870-46FC-A397-B1029EF7C406}" dt="2025-05-13T11:05:49.388" v="3"/>
-          <ac:graphicFrameMkLst>
-            <pc:docMk/>
-            <pc:sldMk cId="3020345181" sldId="257"/>
-            <ac:graphicFrameMk id="6" creationId="{15623DAB-A4E1-DF1C-9B96-E2C1CE9DE49A}"/>
-          </ac:graphicFrameMkLst>
-        </pc:graphicFrameChg>
-      </pc:sldChg>
-    </pc:docChg>
-  </pc:docChgLst>
-  <pc:docChgLst>
-    <pc:chgData name="Fatima Pillosu" userId="a6295d4dc9e22643" providerId="LiveId" clId="{9499B2B4-FAAC-435D-8D03-AF2D062895C2}"/>
-    <pc:docChg chg="undo custSel modSld">
-      <pc:chgData name="Fatima Pillosu" userId="a6295d4dc9e22643" providerId="LiveId" clId="{9499B2B4-FAAC-435D-8D03-AF2D062895C2}" dt="2025-05-26T07:08:59.082" v="624"/>
-      <pc:docMkLst>
-        <pc:docMk/>
-      </pc:docMkLst>
-      <pc:sldChg chg="addSp delSp modSp mod">
-        <pc:chgData name="Fatima Pillosu" userId="a6295d4dc9e22643" providerId="LiveId" clId="{9499B2B4-FAAC-435D-8D03-AF2D062895C2}" dt="2025-05-26T07:08:59.082" v="624"/>
-        <pc:sldMkLst>
-          <pc:docMk/>
-          <pc:sldMk cId="3020345181" sldId="257"/>
-        </pc:sldMkLst>
-        <pc:spChg chg="add del">
-          <ac:chgData name="Fatima Pillosu" userId="a6295d4dc9e22643" providerId="LiveId" clId="{9499B2B4-FAAC-435D-8D03-AF2D062895C2}" dt="2025-05-26T07:08:44.718" v="622" actId="478"/>
-          <ac:spMkLst>
-            <pc:docMk/>
-            <pc:sldMk cId="3020345181" sldId="257"/>
-            <ac:spMk id="2" creationId="{981F020D-F5CA-1A92-0997-181A277B8659}"/>
-          </ac:spMkLst>
-        </pc:spChg>
-        <pc:spChg chg="add del mod">
-          <ac:chgData name="Fatima Pillosu" userId="a6295d4dc9e22643" providerId="LiveId" clId="{9499B2B4-FAAC-435D-8D03-AF2D062895C2}" dt="2025-05-14T14:23:06.044" v="514" actId="21"/>
-          <ac:spMkLst>
-            <pc:docMk/>
-            <pc:sldMk cId="3020345181" sldId="257"/>
-            <ac:spMk id="3" creationId="{BFB118F7-3AF0-A668-608B-98A47405975A}"/>
-          </ac:spMkLst>
-        </pc:spChg>
-        <pc:spChg chg="add del">
-          <ac:chgData name="Fatima Pillosu" userId="a6295d4dc9e22643" providerId="LiveId" clId="{9499B2B4-FAAC-435D-8D03-AF2D062895C2}" dt="2025-05-14T14:23:04.876" v="513" actId="478"/>
-          <ac:spMkLst>
-            <pc:docMk/>
-            <pc:sldMk cId="3020345181" sldId="257"/>
-            <ac:spMk id="4" creationId="{039E4642-ECF9-25B4-2E83-6F9D907104AE}"/>
-          </ac:spMkLst>
-        </pc:spChg>
-        <pc:spChg chg="add del">
-          <ac:chgData name="Fatima Pillosu" userId="a6295d4dc9e22643" providerId="LiveId" clId="{9499B2B4-FAAC-435D-8D03-AF2D062895C2}" dt="2025-05-14T14:13:52.925" v="445" actId="11529"/>
-          <ac:spMkLst>
-            <pc:docMk/>
-            <pc:sldMk cId="3020345181" sldId="257"/>
-            <ac:spMk id="4" creationId="{50632730-3E98-E472-A120-13C9A3B7EC59}"/>
-          </ac:spMkLst>
-        </pc:spChg>
-        <pc:spChg chg="add mod">
-          <ac:chgData name="Fatima Pillosu" userId="a6295d4dc9e22643" providerId="LiveId" clId="{9499B2B4-FAAC-435D-8D03-AF2D062895C2}" dt="2025-05-26T07:08:59.082" v="624"/>
+        <pc:spChg chg="mod">
+          <ac:chgData name="Fatima Pillosu" userId="a6295d4dc9e22643" providerId="LiveId" clId="{87453732-75AC-4426-B5D3-B7C69C2D4F54}" dt="2026-01-15T10:11:32.398" v="1" actId="20577"/>
           <ac:spMkLst>
             <pc:docMk/>
             <pc:sldMk cId="3020345181" sldId="257"/>
             <ac:spMk id="4" creationId="{BFB118F7-3AF0-A668-608B-98A47405975A}"/>
           </ac:spMkLst>
         </pc:spChg>
-        <pc:spChg chg="add del mod">
-          <ac:chgData name="Fatima Pillosu" userId="a6295d4dc9e22643" providerId="LiveId" clId="{9499B2B4-FAAC-435D-8D03-AF2D062895C2}" dt="2025-05-14T14:18:32.659" v="451" actId="21"/>
-          <ac:spMkLst>
-            <pc:docMk/>
-            <pc:sldMk cId="3020345181" sldId="257"/>
-            <ac:spMk id="7" creationId="{BFB118F7-3AF0-A668-608B-98A47405975A}"/>
-          </ac:spMkLst>
-        </pc:spChg>
-        <pc:spChg chg="add del mod">
-          <ac:chgData name="Fatima Pillosu" userId="a6295d4dc9e22643" providerId="LiveId" clId="{9499B2B4-FAAC-435D-8D03-AF2D062895C2}" dt="2025-05-26T07:08:45.774" v="623" actId="21"/>
-          <ac:spMkLst>
-            <pc:docMk/>
-            <pc:sldMk cId="3020345181" sldId="257"/>
-            <ac:spMk id="8" creationId="{BFB118F7-3AF0-A668-608B-98A47405975A}"/>
-          </ac:spMkLst>
-        </pc:spChg>
-        <pc:graphicFrameChg chg="add del mod modGraphic">
-          <ac:chgData name="Fatima Pillosu" userId="a6295d4dc9e22643" providerId="LiveId" clId="{9499B2B4-FAAC-435D-8D03-AF2D062895C2}" dt="2025-05-14T14:23:06.044" v="514" actId="21"/>
-          <ac:graphicFrameMkLst>
-            <pc:docMk/>
-            <pc:sldMk cId="3020345181" sldId="257"/>
-            <ac:graphicFrameMk id="2" creationId="{15623DAB-A4E1-DF1C-9B96-E2C1CE9DE49A}"/>
-          </ac:graphicFrameMkLst>
-        </pc:graphicFrameChg>
-        <pc:graphicFrameChg chg="add mod">
-          <ac:chgData name="Fatima Pillosu" userId="a6295d4dc9e22643" providerId="LiveId" clId="{9499B2B4-FAAC-435D-8D03-AF2D062895C2}" dt="2025-05-26T07:08:59.082" v="624"/>
-          <ac:graphicFrameMkLst>
-            <pc:docMk/>
-            <pc:sldMk cId="3020345181" sldId="257"/>
-            <ac:graphicFrameMk id="3" creationId="{15623DAB-A4E1-DF1C-9B96-E2C1CE9DE49A}"/>
-          </ac:graphicFrameMkLst>
-        </pc:graphicFrameChg>
-        <pc:graphicFrameChg chg="add del mod modGraphic">
-          <ac:chgData name="Fatima Pillosu" userId="a6295d4dc9e22643" providerId="LiveId" clId="{9499B2B4-FAAC-435D-8D03-AF2D062895C2}" dt="2025-05-14T14:18:32.659" v="451" actId="21"/>
-          <ac:graphicFrameMkLst>
-            <pc:docMk/>
-            <pc:sldMk cId="3020345181" sldId="257"/>
-            <ac:graphicFrameMk id="5" creationId="{15623DAB-A4E1-DF1C-9B96-E2C1CE9DE49A}"/>
-          </ac:graphicFrameMkLst>
-        </pc:graphicFrameChg>
-        <pc:graphicFrameChg chg="add del mod modGraphic">
-          <ac:chgData name="Fatima Pillosu" userId="a6295d4dc9e22643" providerId="LiveId" clId="{9499B2B4-FAAC-435D-8D03-AF2D062895C2}" dt="2025-05-26T07:08:45.774" v="623" actId="21"/>
-          <ac:graphicFrameMkLst>
-            <pc:docMk/>
-            <pc:sldMk cId="3020345181" sldId="257"/>
-            <ac:graphicFrameMk id="6" creationId="{15623DAB-A4E1-DF1C-9B96-E2C1CE9DE49A}"/>
-          </ac:graphicFrameMkLst>
-        </pc:graphicFrameChg>
-      </pc:sldChg>
-    </pc:docChg>
-  </pc:docChgLst>
-  <pc:docChgLst>
-    <pc:chgData name="Fatima Pillosu" userId="a6295d4dc9e22643" providerId="LiveId" clId="{99324F6C-297E-4162-BC49-3E327AE98FF2}"/>
-    <pc:docChg chg="modSld">
-      <pc:chgData name="Fatima Pillosu" userId="a6295d4dc9e22643" providerId="LiveId" clId="{99324F6C-297E-4162-BC49-3E327AE98FF2}" dt="2025-07-14T20:15:51.029" v="34" actId="6549"/>
-      <pc:docMkLst>
-        <pc:docMk/>
-      </pc:docMkLst>
-      <pc:sldChg chg="modSp mod">
-        <pc:chgData name="Fatima Pillosu" userId="a6295d4dc9e22643" providerId="LiveId" clId="{99324F6C-297E-4162-BC49-3E327AE98FF2}" dt="2025-07-14T20:15:51.029" v="34" actId="6549"/>
-        <pc:sldMkLst>
-          <pc:docMk/>
-          <pc:sldMk cId="3020345181" sldId="257"/>
-        </pc:sldMkLst>
-        <pc:spChg chg="mod">
-          <ac:chgData name="Fatima Pillosu" userId="a6295d4dc9e22643" providerId="LiveId" clId="{99324F6C-297E-4162-BC49-3E327AE98FF2}" dt="2025-07-14T20:15:26.670" v="14" actId="20577"/>
-          <ac:spMkLst>
-            <pc:docMk/>
-            <pc:sldMk cId="3020345181" sldId="257"/>
-            <ac:spMk id="4" creationId="{BFB118F7-3AF0-A668-608B-98A47405975A}"/>
-          </ac:spMkLst>
-        </pc:spChg>
-        <pc:graphicFrameChg chg="modGraphic">
-          <ac:chgData name="Fatima Pillosu" userId="a6295d4dc9e22643" providerId="LiveId" clId="{99324F6C-297E-4162-BC49-3E327AE98FF2}" dt="2025-07-14T20:15:51.029" v="34" actId="6549"/>
-          <ac:graphicFrameMkLst>
-            <pc:docMk/>
-            <pc:sldMk cId="3020345181" sldId="257"/>
-            <ac:graphicFrameMk id="3" creationId="{15623DAB-A4E1-DF1C-9B96-E2C1CE9DE49A}"/>
-          </ac:graphicFrameMkLst>
-        </pc:graphicFrameChg>
       </pc:sldChg>
     </pc:docChg>
   </pc:docChgLst>
@@ -424,7 +272,7 @@
           <a:p>
             <a:fld id="{1FB3EBC5-2BAE-4ECB-A995-B52653FE7498}" type="datetimeFigureOut">
               <a:rPr lang="en-GB" smtClean="0"/>
-              <a:t>14/07/2025</a:t>
+              <a:t>15/01/2026</a:t>
             </a:fld>
             <a:endParaRPr lang="en-GB"/>
           </a:p>
@@ -594,7 +442,7 @@
           <a:p>
             <a:fld id="{1FB3EBC5-2BAE-4ECB-A995-B52653FE7498}" type="datetimeFigureOut">
               <a:rPr lang="en-GB" smtClean="0"/>
-              <a:t>14/07/2025</a:t>
+              <a:t>15/01/2026</a:t>
             </a:fld>
             <a:endParaRPr lang="en-GB"/>
           </a:p>
@@ -774,7 +622,7 @@
           <a:p>
             <a:fld id="{1FB3EBC5-2BAE-4ECB-A995-B52653FE7498}" type="datetimeFigureOut">
               <a:rPr lang="en-GB" smtClean="0"/>
-              <a:t>14/07/2025</a:t>
+              <a:t>15/01/2026</a:t>
             </a:fld>
             <a:endParaRPr lang="en-GB"/>
           </a:p>
@@ -944,7 +792,7 @@
           <a:p>
             <a:fld id="{1FB3EBC5-2BAE-4ECB-A995-B52653FE7498}" type="datetimeFigureOut">
               <a:rPr lang="en-GB" smtClean="0"/>
-              <a:t>14/07/2025</a:t>
+              <a:t>15/01/2026</a:t>
             </a:fld>
             <a:endParaRPr lang="en-GB"/>
           </a:p>
@@ -1190,7 +1038,7 @@
           <a:p>
             <a:fld id="{1FB3EBC5-2BAE-4ECB-A995-B52653FE7498}" type="datetimeFigureOut">
               <a:rPr lang="en-GB" smtClean="0"/>
-              <a:t>14/07/2025</a:t>
+              <a:t>15/01/2026</a:t>
             </a:fld>
             <a:endParaRPr lang="en-GB"/>
           </a:p>
@@ -1422,7 +1270,7 @@
           <a:p>
             <a:fld id="{1FB3EBC5-2BAE-4ECB-A995-B52653FE7498}" type="datetimeFigureOut">
               <a:rPr lang="en-GB" smtClean="0"/>
-              <a:t>14/07/2025</a:t>
+              <a:t>15/01/2026</a:t>
             </a:fld>
             <a:endParaRPr lang="en-GB"/>
           </a:p>
@@ -1789,7 +1637,7 @@
           <a:p>
             <a:fld id="{1FB3EBC5-2BAE-4ECB-A995-B52653FE7498}" type="datetimeFigureOut">
               <a:rPr lang="en-GB" smtClean="0"/>
-              <a:t>14/07/2025</a:t>
+              <a:t>15/01/2026</a:t>
             </a:fld>
             <a:endParaRPr lang="en-GB"/>
           </a:p>
@@ -1907,7 +1755,7 @@
           <a:p>
             <a:fld id="{1FB3EBC5-2BAE-4ECB-A995-B52653FE7498}" type="datetimeFigureOut">
               <a:rPr lang="en-GB" smtClean="0"/>
-              <a:t>14/07/2025</a:t>
+              <a:t>15/01/2026</a:t>
             </a:fld>
             <a:endParaRPr lang="en-GB"/>
           </a:p>
@@ -2002,7 +1850,7 @@
           <a:p>
             <a:fld id="{1FB3EBC5-2BAE-4ECB-A995-B52653FE7498}" type="datetimeFigureOut">
               <a:rPr lang="en-GB" smtClean="0"/>
-              <a:t>14/07/2025</a:t>
+              <a:t>15/01/2026</a:t>
             </a:fld>
             <a:endParaRPr lang="en-GB"/>
           </a:p>
@@ -2279,7 +2127,7 @@
           <a:p>
             <a:fld id="{1FB3EBC5-2BAE-4ECB-A995-B52653FE7498}" type="datetimeFigureOut">
               <a:rPr lang="en-GB" smtClean="0"/>
-              <a:t>14/07/2025</a:t>
+              <a:t>15/01/2026</a:t>
             </a:fld>
             <a:endParaRPr lang="en-GB"/>
           </a:p>
@@ -2536,7 +2384,7 @@
           <a:p>
             <a:fld id="{1FB3EBC5-2BAE-4ECB-A995-B52653FE7498}" type="datetimeFigureOut">
               <a:rPr lang="en-GB" smtClean="0"/>
-              <a:t>14/07/2025</a:t>
+              <a:t>15/01/2026</a:t>
             </a:fld>
             <a:endParaRPr lang="en-GB"/>
           </a:p>
@@ -2749,7 +2597,7 @@
           <a:p>
             <a:fld id="{1FB3EBC5-2BAE-4ECB-A995-B52653FE7498}" type="datetimeFigureOut">
               <a:rPr lang="en-GB" smtClean="0"/>
-              <a:t>14/07/2025</a:t>
+              <a:t>15/01/2026</a:t>
             </a:fld>
             <a:endParaRPr lang="en-GB"/>
           </a:p>
@@ -3865,7 +3713,31 @@
                 </a:solidFill>
                 <a:latin typeface="Avenir Next LT Pro" panose="020B0504020202020204" pitchFamily="34" charset="0"/>
               </a:rPr>
-              <a:t>IFS Cycle 31r2, </a:t>
+              <a:t>IFS </a:t>
+            </a:r>
+            <a:r>
+              <a:rPr lang="en-US" sz="800">
+                <a:solidFill>
+                  <a:schemeClr val="tx1">
+                    <a:lumMod val="95000"/>
+                    <a:lumOff val="5000"/>
+                  </a:schemeClr>
+                </a:solidFill>
+                <a:latin typeface="Avenir Next LT Pro" panose="020B0504020202020204" pitchFamily="34" charset="0"/>
+              </a:rPr>
+              <a:t>Cycle 41r2</a:t>
+            </a:r>
+            <a:r>
+              <a:rPr lang="en-US" sz="800" dirty="0">
+                <a:solidFill>
+                  <a:schemeClr val="tx1">
+                    <a:lumMod val="95000"/>
+                    <a:lumOff val="5000"/>
+                  </a:schemeClr>
+                </a:solidFill>
+                <a:latin typeface="Avenir Next LT Pro" panose="020B0504020202020204" pitchFamily="34" charset="0"/>
+              </a:rPr>
+              <a:t>, </a:t>
             </a:r>
             <a:r>
               <a:rPr lang="en-US" sz="800" dirty="0">

</xml_diff>